<commit_message>
Update major project presentation file
</commit_message>
<xml_diff>
--- a/VOIS_Major_Project.pptx
+++ b/VOIS_Major_Project.pptx
@@ -12954,7 +12954,7 @@
           <a:p>
             <a:r>
               <a:rPr lang="en-US" dirty="0">
-                <a:hlinkClick r:id="rId2" tooltip="" action="ppaction://hlinkfile"/>
+                <a:hlinkClick r:id="rId2" action="ppaction://hlinkfile"/>
               </a:rPr>
               <a:t>https://github.com/deba-biswas/seasonal-agriculture-analysis.git</a:t>
             </a:r>
@@ -22451,38 +22451,6 @@
           </a:effectLst>
         </p:spPr>
       </p:pic>
-      <p:pic>
-        <p:nvPicPr>
-          <p:cNvPr id="3" name="Picture 2"/>
-          <p:cNvPicPr>
-            <a:picLocks noChangeAspect="1"/>
-          </p:cNvPicPr>
-          <p:nvPr/>
-        </p:nvPicPr>
-        <p:blipFill>
-          <a:blip r:embed="rId3"/>
-          <a:stretch>
-            <a:fillRect/>
-          </a:stretch>
-        </p:blipFill>
-        <p:spPr>
-          <a:xfrm>
-            <a:off x="6217285" y="1275080"/>
-            <a:ext cx="4836160" cy="2985770"/>
-          </a:xfrm>
-          <a:prstGeom prst="rect">
-            <a:avLst/>
-          </a:prstGeom>
-          <a:effectLst>
-            <a:glow rad="63500">
-              <a:schemeClr val="accent1">
-                <a:satMod val="175000"/>
-                <a:alpha val="40000"/>
-              </a:schemeClr>
-            </a:glow>
-          </a:effectLst>
-        </p:spPr>
-      </p:pic>
       <p:sp>
         <p:nvSpPr>
           <p:cNvPr id="6" name="Text Box 5"/>
@@ -22679,6 +22647,38 @@
           </a:p>
         </p:txBody>
       </p:sp>
+      <p:pic>
+        <p:nvPicPr>
+          <p:cNvPr id="10" name="Picture 9"/>
+          <p:cNvPicPr>
+            <a:picLocks noChangeAspect="1"/>
+          </p:cNvPicPr>
+          <p:nvPr/>
+        </p:nvPicPr>
+        <p:blipFill>
+          <a:blip r:embed="rId3"/>
+          <a:stretch>
+            <a:fillRect/>
+          </a:stretch>
+        </p:blipFill>
+        <p:spPr>
+          <a:xfrm>
+            <a:off x="6561455" y="1201420"/>
+            <a:ext cx="5069205" cy="3129915"/>
+          </a:xfrm>
+          <a:prstGeom prst="rect">
+            <a:avLst/>
+          </a:prstGeom>
+          <a:effectLst>
+            <a:glow rad="63500">
+              <a:schemeClr val="accent1">
+                <a:satMod val="175000"/>
+                <a:alpha val="40000"/>
+              </a:schemeClr>
+            </a:glow>
+          </a:effectLst>
+        </p:spPr>
+      </p:pic>
     </p:spTree>
   </p:cSld>
   <p:clrMapOvr>

</xml_diff>